<commit_message>
fix: corrige errores que existia en conjunto de el proyecto
</commit_message>
<xml_diff>
--- a/informe/presentacion.pptx
+++ b/informe/presentacion.pptx
@@ -15,6 +15,9 @@
     <p:sldId id="263" r:id="rId14"/>
     <p:sldId id="264" r:id="rId15"/>
     <p:sldId id="265" r:id="rId16"/>
+    <p:sldId id="266" r:id="rId17"/>
+    <p:sldId id="267" r:id="rId18"/>
+    <p:sldId id="268" r:id="rId19"/>
   </p:sldIdLst>
   <p:sldSz cx="12191695" cy="6858000" type="screen4x3"/>
   <p:notesSz cx="6858000" cy="9144000"/>
@@ -3254,6 +3257,444 @@
               </a:defRPr>
             </a:pPr>
             <a:r>
+              <a:t>Pregunta 4: umbral de tolerancia</a:t>
+            </a:r>
+          </a:p>
+        </p:txBody>
+      </p:sp>
+      <p:sp>
+        <p:nvSpPr>
+          <p:cNvPr id="3" name="TextBox 2"/>
+          <p:cNvSpPr txBox="1"/>
+          <p:nvPr/>
+        </p:nvSpPr>
+        <p:spPr>
+          <a:xfrm>
+            <a:off x="548640" y="1371600"/>
+            <a:ext cx="5120640" cy="5029200"/>
+          </a:xfrm>
+          <a:prstGeom prst="rect">
+            <a:avLst/>
+          </a:prstGeom>
+          <a:noFill/>
+        </p:spPr>
+        <p:txBody>
+          <a:bodyPr wrap="square">
+            <a:spAutoFit/>
+          </a:bodyPr>
+          <a:lstStyle/>
+          <a:p>
+            <a:pPr>
+              <a:spcAft>
+                <a:spcPts val="800"/>
+              </a:spcAft>
+              <a:defRPr sz="1800">
+                <a:latin typeface="Times New Roman"/>
+              </a:defRPr>
+            </a:pPr>
+            <a:r>
+              <a:t>• Cerca de 18 Bs la demanda cae ~10 solicitudes por Bs</a:t>
+            </a:r>
+          </a:p>
+          <a:p>
+            <a:pPr>
+              <a:spcAft>
+                <a:spcPts val="800"/>
+              </a:spcAft>
+              <a:defRPr sz="1800">
+                <a:latin typeface="Times New Roman"/>
+              </a:defRPr>
+            </a:pPr>
+            <a:r>
+              <a:t>• Con α = 0,1 el precio salta entre 5 y 35 Bs: hay que bajar α</a:t>
+            </a:r>
+          </a:p>
+          <a:p>
+            <a:pPr>
+              <a:spcAft>
+                <a:spcPts val="800"/>
+              </a:spcAft>
+              <a:defRPr sz="1800">
+                <a:latin typeface="Times New Roman"/>
+              </a:defRPr>
+            </a:pPr>
+            <a:r>
+              <a:t>• Solo precio: KF lineal 1,48 Bs, EKF 0,38 Bs, UKF 0,36 Bs</a:t>
+            </a:r>
+          </a:p>
+          <a:p>
+            <a:pPr>
+              <a:spcAft>
+                <a:spcPts val="800"/>
+              </a:spcAft>
+              <a:defRPr sz="1800">
+                <a:latin typeface="Times New Roman"/>
+              </a:defRPr>
+            </a:pPr>
+            <a:r>
+              <a:t>• EKF suficiente; UKF más robusto al arranque</a:t>
+            </a:r>
+          </a:p>
+        </p:txBody>
+      </p:sp>
+      <p:pic>
+        <p:nvPicPr>
+          <p:cNvPr id="4" name="Picture 3" descr="no_lineal_dinamica.png"/>
+          <p:cNvPicPr>
+            <a:picLocks noChangeAspect="1"/>
+          </p:cNvPicPr>
+          <p:nvPr/>
+        </p:nvPicPr>
+        <p:blipFill>
+          <a:blip r:embed="rId2"/>
+          <a:stretch>
+            <a:fillRect/>
+          </a:stretch>
+        </p:blipFill>
+        <p:spPr>
+          <a:xfrm>
+            <a:off x="5852160" y="1371600"/>
+            <a:ext cx="6035040" cy="2089052"/>
+          </a:xfrm>
+          <a:prstGeom prst="rect">
+            <a:avLst/>
+          </a:prstGeom>
+        </p:spPr>
+      </p:pic>
+    </p:spTree>
+  </p:cSld>
+  <p:clrMapOvr>
+    <a:masterClrMapping/>
+  </p:clrMapOvr>
+</p:sld>
+</file>
+
+<file path=ppt/slides/slide11.xml><?xml version="1.0" encoding="utf-8"?>
+<p:sld xmlns:a="http://schemas.openxmlformats.org/drawingml/2006/main" xmlns:p="http://schemas.openxmlformats.org/presentationml/2006/main" xmlns:r="http://schemas.openxmlformats.org/officeDocument/2006/relationships">
+  <p:cSld>
+    <p:spTree>
+      <p:nvGrpSpPr>
+        <p:cNvPr id="1" name=""/>
+        <p:cNvGrpSpPr/>
+        <p:nvPr/>
+      </p:nvGrpSpPr>
+      <p:grpSpPr/>
+      <p:sp>
+        <p:nvSpPr>
+          <p:cNvPr id="2" name="Title 1"/>
+          <p:cNvSpPr>
+            <a:spLocks noGrp="1"/>
+          </p:cNvSpPr>
+          <p:nvPr>
+            <p:ph type="title"/>
+          </p:nvPr>
+        </p:nvSpPr>
+        <p:spPr/>
+        <p:txBody>
+          <a:bodyPr/>
+          <a:lstStyle/>
+          <a:p>
+            <a:pPr>
+              <a:defRPr sz="3000">
+                <a:solidFill>
+                  <a:srgbClr val="000000"/>
+                </a:solidFill>
+                <a:latin typeface="Times New Roman"/>
+              </a:defRPr>
+            </a:pPr>
+            <a:r>
+              <a:t>Pregunta 6: lluvia vs hora punta</a:t>
+            </a:r>
+          </a:p>
+        </p:txBody>
+      </p:sp>
+      <p:sp>
+        <p:nvSpPr>
+          <p:cNvPr id="3" name="TextBox 2"/>
+          <p:cNvSpPr txBox="1"/>
+          <p:nvPr/>
+        </p:nvSpPr>
+        <p:spPr>
+          <a:xfrm>
+            <a:off x="548640" y="1371600"/>
+            <a:ext cx="5120640" cy="5029200"/>
+          </a:xfrm>
+          <a:prstGeom prst="rect">
+            <a:avLst/>
+          </a:prstGeom>
+          <a:noFill/>
+        </p:spPr>
+        <p:txBody>
+          <a:bodyPr wrap="square">
+            <a:spAutoFit/>
+          </a:bodyPr>
+          <a:lstStyle/>
+          <a:p>
+            <a:pPr>
+              <a:spcAft>
+                <a:spcPts val="800"/>
+              </a:spcAft>
+              <a:defRPr sz="1800">
+                <a:latin typeface="Times New Roman"/>
+              </a:defRPr>
+            </a:pPr>
+            <a:r>
+              <a:t>• En la red: efectos casi aditivos (interacción ≈ 0,04)</a:t>
+            </a:r>
+          </a:p>
+          <a:p>
+            <a:pPr>
+              <a:spcAft>
+                <a:spcPts val="800"/>
+              </a:spcAft>
+              <a:defRPr sz="1800">
+                <a:latin typeface="Times New Roman"/>
+              </a:defRPr>
+            </a:pPr>
+            <a:r>
+              <a:t>• En los datos, diferencia ingenua de la lluvia: +22,6 solicitudes</a:t>
+            </a:r>
+          </a:p>
+          <a:p>
+            <a:pPr>
+              <a:spcAft>
+                <a:spcPts val="800"/>
+              </a:spcAft>
+              <a:defRPr sz="1800">
+                <a:latin typeface="Times New Roman"/>
+              </a:defRPr>
+            </a:pPr>
+            <a:r>
+              <a:t>• Regresión con todos los factores: +10,0 (generador: +10)</a:t>
+            </a:r>
+          </a:p>
+          <a:p>
+            <a:pPr>
+              <a:spcAft>
+                <a:spcPts val="800"/>
+              </a:spcAft>
+              <a:defRPr sz="1800">
+                <a:latin typeface="Times New Roman"/>
+              </a:defRPr>
+            </a:pPr>
+            <a:r>
+              <a:t>• Hace falta lluvia fuera de la hora punta y registrar todo el contexto</a:t>
+            </a:r>
+          </a:p>
+        </p:txBody>
+      </p:sp>
+      <p:pic>
+        <p:nvPicPr>
+          <p:cNvPr id="4" name="Picture 3" descr="pregunta6.png"/>
+          <p:cNvPicPr>
+            <a:picLocks noChangeAspect="1"/>
+          </p:cNvPicPr>
+          <p:nvPr/>
+        </p:nvPicPr>
+        <p:blipFill>
+          <a:blip r:embed="rId2"/>
+          <a:stretch>
+            <a:fillRect/>
+          </a:stretch>
+        </p:blipFill>
+        <p:spPr>
+          <a:xfrm>
+            <a:off x="5852160" y="1371600"/>
+            <a:ext cx="6035040" cy="4023360"/>
+          </a:xfrm>
+          <a:prstGeom prst="rect">
+            <a:avLst/>
+          </a:prstGeom>
+        </p:spPr>
+      </p:pic>
+    </p:spTree>
+  </p:cSld>
+  <p:clrMapOvr>
+    <a:masterClrMapping/>
+  </p:clrMapOvr>
+</p:sld>
+</file>
+
+<file path=ppt/slides/slide12.xml><?xml version="1.0" encoding="utf-8"?>
+<p:sld xmlns:a="http://schemas.openxmlformats.org/drawingml/2006/main" xmlns:p="http://schemas.openxmlformats.org/presentationml/2006/main" xmlns:r="http://schemas.openxmlformats.org/officeDocument/2006/relationships">
+  <p:cSld>
+    <p:spTree>
+      <p:nvGrpSpPr>
+        <p:cNvPr id="1" name=""/>
+        <p:cNvGrpSpPr/>
+        <p:nvPr/>
+      </p:nvGrpSpPr>
+      <p:grpSpPr/>
+      <p:sp>
+        <p:nvSpPr>
+          <p:cNvPr id="2" name="Title 1"/>
+          <p:cNvSpPr>
+            <a:spLocks noGrp="1"/>
+          </p:cNvSpPr>
+          <p:nvPr>
+            <p:ph type="title"/>
+          </p:nvPr>
+        </p:nvSpPr>
+        <p:spPr/>
+        <p:txBody>
+          <a:bodyPr/>
+          <a:lstStyle/>
+          <a:p>
+            <a:pPr>
+              <a:defRPr sz="3000">
+                <a:solidFill>
+                  <a:srgbClr val="000000"/>
+                </a:solidFill>
+                <a:latin typeface="Times New Roman"/>
+              </a:defRPr>
+            </a:pPr>
+            <a:r>
+              <a:t>Decisión de tarifa (pregunta 7)</a:t>
+            </a:r>
+          </a:p>
+        </p:txBody>
+      </p:sp>
+      <p:sp>
+        <p:nvSpPr>
+          <p:cNvPr id="3" name="TextBox 2"/>
+          <p:cNvSpPr txBox="1"/>
+          <p:nvPr/>
+        </p:nvSpPr>
+        <p:spPr>
+          <a:xfrm>
+            <a:off x="548640" y="1371600"/>
+            <a:ext cx="5120640" cy="5029200"/>
+          </a:xfrm>
+          <a:prstGeom prst="rect">
+            <a:avLst/>
+          </a:prstGeom>
+          <a:noFill/>
+        </p:spPr>
+        <p:txBody>
+          <a:bodyPr wrap="square">
+            <a:spAutoFit/>
+          </a:bodyPr>
+          <a:lstStyle/>
+          <a:p>
+            <a:pPr>
+              <a:spcAft>
+                <a:spcPts val="800"/>
+              </a:spcAft>
+              <a:defRPr sz="1800">
+                <a:latin typeface="Times New Roman"/>
+              </a:defRPr>
+            </a:pPr>
+            <a:r>
+              <a:t>• INCENTIVAR si P(escasez) &gt; 0,30 y el límite inferior del precio &gt; 13 Bs</a:t>
+            </a:r>
+          </a:p>
+          <a:p>
+            <a:pPr>
+              <a:spcAft>
+                <a:spcPts val="800"/>
+              </a:spcAft>
+              <a:defRPr sz="1800">
+                <a:latin typeface="Times New Roman"/>
+              </a:defRPr>
+            </a:pPr>
+            <a:r>
+              <a:t>• SUBIR si P(escasez) &gt; X y el precio aún no es alto con seguridad</a:t>
+            </a:r>
+          </a:p>
+          <a:p>
+            <a:pPr>
+              <a:spcAft>
+                <a:spcPts val="800"/>
+              </a:spcAft>
+              <a:defRPr sz="1800">
+                <a:latin typeface="Times New Roman"/>
+              </a:defRPr>
+            </a:pPr>
+            <a:r>
+              <a:t>• B: +1,1 % servicios; C: +1,2 %</a:t>
+            </a:r>
+          </a:p>
+          <a:p>
+            <a:pPr>
+              <a:spcAft>
+                <a:spcPts val="800"/>
+              </a:spcAft>
+              <a:defRPr sz="1800">
+                <a:latin typeface="Times New Roman"/>
+              </a:defRPr>
+            </a:pPr>
+            <a:r>
+              <a:t>• Permanencia mínima de 30 min para evitar parpadeo</a:t>
+            </a:r>
+          </a:p>
+        </p:txBody>
+      </p:sp>
+      <p:pic>
+        <p:nvPicPr>
+          <p:cNvPr id="4" name="Picture 3" descr="decision_barrido.png"/>
+          <p:cNvPicPr>
+            <a:picLocks noChangeAspect="1"/>
+          </p:cNvPicPr>
+          <p:nvPr/>
+        </p:nvPicPr>
+        <p:blipFill>
+          <a:blip r:embed="rId2"/>
+          <a:stretch>
+            <a:fillRect/>
+          </a:stretch>
+        </p:blipFill>
+        <p:spPr>
+          <a:xfrm>
+            <a:off x="5852160" y="1371600"/>
+            <a:ext cx="6035040" cy="1697355"/>
+          </a:xfrm>
+          <a:prstGeom prst="rect">
+            <a:avLst/>
+          </a:prstGeom>
+        </p:spPr>
+      </p:pic>
+    </p:spTree>
+  </p:cSld>
+  <p:clrMapOvr>
+    <a:masterClrMapping/>
+  </p:clrMapOvr>
+</p:sld>
+</file>
+
+<file path=ppt/slides/slide13.xml><?xml version="1.0" encoding="utf-8"?>
+<p:sld xmlns:a="http://schemas.openxmlformats.org/drawingml/2006/main" xmlns:p="http://schemas.openxmlformats.org/presentationml/2006/main" xmlns:r="http://schemas.openxmlformats.org/officeDocument/2006/relationships">
+  <p:cSld>
+    <p:spTree>
+      <p:nvGrpSpPr>
+        <p:cNvPr id="1" name=""/>
+        <p:cNvGrpSpPr/>
+        <p:nvPr/>
+      </p:nvGrpSpPr>
+      <p:grpSpPr/>
+      <p:sp>
+        <p:nvSpPr>
+          <p:cNvPr id="2" name="Title 1"/>
+          <p:cNvSpPr>
+            <a:spLocks noGrp="1"/>
+          </p:cNvSpPr>
+          <p:nvPr>
+            <p:ph type="title"/>
+          </p:nvPr>
+        </p:nvSpPr>
+        <p:spPr/>
+        <p:txBody>
+          <a:bodyPr/>
+          <a:lstStyle/>
+          <a:p>
+            <a:pPr>
+              <a:defRPr sz="3000">
+                <a:solidFill>
+                  <a:srgbClr val="000000"/>
+                </a:solidFill>
+                <a:latin typeface="Times New Roman"/>
+              </a:defRPr>
+            </a:pPr>
+            <a:r>
               <a:t>Conclusiones y limitaciones</a:t>
             </a:r>
           </a:p>
@@ -3342,7 +3783,7 @@
               </a:defRPr>
             </a:pPr>
             <a:r>
-              <a:t>• Reproducible: pip install -r requirements.txt y los scripts del README</a:t>
+              <a:t>• Reproducible: pip install -r requirements.txt y python reproducir.py</a:t>
             </a:r>
           </a:p>
         </p:txBody>
@@ -4258,7 +4699,7 @@
               </a:defRPr>
             </a:pPr>
             <a:r>
-              <a:t>Decisión de tarifa (pregunta 7)</a:t>
+              <a:t>Pregunta 1: sensibilidad</a:t>
             </a:r>
           </a:p>
         </p:txBody>
@@ -4294,7 +4735,7 @@
               </a:defRPr>
             </a:pPr>
             <a:r>
-              <a:t>• INCENTIVAR si P(escasez) &gt; 0,30 y el límite inferior del precio &gt; 13 Bs</a:t>
+              <a:t>• α nominal a 14 % del límite de estabilidad (α &lt; 0,114)</a:t>
             </a:r>
           </a:p>
           <a:p>
@@ -4307,7 +4748,7 @@
               </a:defRPr>
             </a:pPr>
             <a:r>
-              <a:t>• SUBIR si P(escasez) &gt; X y el precio aún no es alto con seguridad</a:t>
+              <a:t>• Con α/2: equilibrio en 10 min sin oscilar</a:t>
             </a:r>
           </a:p>
           <a:p>
@@ -4320,7 +4761,7 @@
               </a:defRPr>
             </a:pPr>
             <a:r>
-              <a:t>• B: +1,1 % servicios; C: +1,2 %</a:t>
+              <a:t>• β y γ mueven p* en sentidos opuestos; la dinámica depende de β + γ</a:t>
             </a:r>
           </a:p>
           <a:p>
@@ -4333,14 +4774,14 @@
               </a:defRPr>
             </a:pPr>
             <a:r>
-              <a:t>• Permanencia mínima de 30 min para evitar parpadeo</a:t>
+              <a:t>• Estimar con más precisión α y β</a:t>
             </a:r>
           </a:p>
         </p:txBody>
       </p:sp>
       <p:pic>
         <p:nvPicPr>
-          <p:cNvPr id="4" name="Picture 3" descr="decision_barrido.png"/>
+          <p:cNvPr id="4" name="Picture 3" descr="sensibilidad_parametros.png"/>
           <p:cNvPicPr>
             <a:picLocks noChangeAspect="1"/>
           </p:cNvPicPr>
@@ -4355,7 +4796,7 @@
         <p:spPr>
           <a:xfrm>
             <a:off x="5852160" y="1371600"/>
-            <a:ext cx="6035040" cy="1697355"/>
+            <a:ext cx="6035040" cy="1609344"/>
           </a:xfrm>
           <a:prstGeom prst="rect">
             <a:avLst/>

</xml_diff>